<commit_message>
Moved inserts to new folder
</commit_message>
<xml_diff>
--- a/HGT_filtering-pipeline.pptx
+++ b/HGT_filtering-pipeline.pptx
@@ -243,7 +243,7 @@
           <a:p>
             <a:fld id="{9386A93F-6D44-2341-95C7-2E010A24378A}" type="datetimeFigureOut">
               <a:rPr lang="en-US" smtClean="0"/>
-              <a:t>5/1/25</a:t>
+              <a:t>5/7/25</a:t>
             </a:fld>
             <a:endParaRPr lang="en-US"/>
           </a:p>
@@ -413,7 +413,7 @@
           <a:p>
             <a:fld id="{9386A93F-6D44-2341-95C7-2E010A24378A}" type="datetimeFigureOut">
               <a:rPr lang="en-US" smtClean="0"/>
-              <a:t>5/1/25</a:t>
+              <a:t>5/7/25</a:t>
             </a:fld>
             <a:endParaRPr lang="en-US"/>
           </a:p>
@@ -593,7 +593,7 @@
           <a:p>
             <a:fld id="{9386A93F-6D44-2341-95C7-2E010A24378A}" type="datetimeFigureOut">
               <a:rPr lang="en-US" smtClean="0"/>
-              <a:t>5/1/25</a:t>
+              <a:t>5/7/25</a:t>
             </a:fld>
             <a:endParaRPr lang="en-US"/>
           </a:p>
@@ -763,7 +763,7 @@
           <a:p>
             <a:fld id="{9386A93F-6D44-2341-95C7-2E010A24378A}" type="datetimeFigureOut">
               <a:rPr lang="en-US" smtClean="0"/>
-              <a:t>5/1/25</a:t>
+              <a:t>5/7/25</a:t>
             </a:fld>
             <a:endParaRPr lang="en-US"/>
           </a:p>
@@ -1009,7 +1009,7 @@
           <a:p>
             <a:fld id="{9386A93F-6D44-2341-95C7-2E010A24378A}" type="datetimeFigureOut">
               <a:rPr lang="en-US" smtClean="0"/>
-              <a:t>5/1/25</a:t>
+              <a:t>5/7/25</a:t>
             </a:fld>
             <a:endParaRPr lang="en-US"/>
           </a:p>
@@ -1241,7 +1241,7 @@
           <a:p>
             <a:fld id="{9386A93F-6D44-2341-95C7-2E010A24378A}" type="datetimeFigureOut">
               <a:rPr lang="en-US" smtClean="0"/>
-              <a:t>5/1/25</a:t>
+              <a:t>5/7/25</a:t>
             </a:fld>
             <a:endParaRPr lang="en-US"/>
           </a:p>
@@ -1608,7 +1608,7 @@
           <a:p>
             <a:fld id="{9386A93F-6D44-2341-95C7-2E010A24378A}" type="datetimeFigureOut">
               <a:rPr lang="en-US" smtClean="0"/>
-              <a:t>5/1/25</a:t>
+              <a:t>5/7/25</a:t>
             </a:fld>
             <a:endParaRPr lang="en-US"/>
           </a:p>
@@ -1726,7 +1726,7 @@
           <a:p>
             <a:fld id="{9386A93F-6D44-2341-95C7-2E010A24378A}" type="datetimeFigureOut">
               <a:rPr lang="en-US" smtClean="0"/>
-              <a:t>5/1/25</a:t>
+              <a:t>5/7/25</a:t>
             </a:fld>
             <a:endParaRPr lang="en-US"/>
           </a:p>
@@ -1821,7 +1821,7 @@
           <a:p>
             <a:fld id="{9386A93F-6D44-2341-95C7-2E010A24378A}" type="datetimeFigureOut">
               <a:rPr lang="en-US" smtClean="0"/>
-              <a:t>5/1/25</a:t>
+              <a:t>5/7/25</a:t>
             </a:fld>
             <a:endParaRPr lang="en-US"/>
           </a:p>
@@ -2098,7 +2098,7 @@
           <a:p>
             <a:fld id="{9386A93F-6D44-2341-95C7-2E010A24378A}" type="datetimeFigureOut">
               <a:rPr lang="en-US" smtClean="0"/>
-              <a:t>5/1/25</a:t>
+              <a:t>5/7/25</a:t>
             </a:fld>
             <a:endParaRPr lang="en-US"/>
           </a:p>
@@ -2355,7 +2355,7 @@
           <a:p>
             <a:fld id="{9386A93F-6D44-2341-95C7-2E010A24378A}" type="datetimeFigureOut">
               <a:rPr lang="en-US" smtClean="0"/>
-              <a:t>5/1/25</a:t>
+              <a:t>5/7/25</a:t>
             </a:fld>
             <a:endParaRPr lang="en-US"/>
           </a:p>
@@ -2568,7 +2568,7 @@
           <a:p>
             <a:fld id="{9386A93F-6D44-2341-95C7-2E010A24378A}" type="datetimeFigureOut">
               <a:rPr lang="en-US" smtClean="0"/>
-              <a:t>5/1/25</a:t>
+              <a:t>5/7/25</a:t>
             </a:fld>
             <a:endParaRPr lang="en-US"/>
           </a:p>
@@ -5342,6 +5342,142 @@
           </a:p>
         </p:txBody>
       </p:sp>
+      <p:sp>
+        <p:nvSpPr>
+          <p:cNvPr id="46" name="Sun 45">
+            <a:extLst>
+              <a:ext uri="{FF2B5EF4-FFF2-40B4-BE49-F238E27FC236}">
+                <a16:creationId xmlns:a16="http://schemas.microsoft.com/office/drawing/2014/main" id="{D05C800A-54C5-F74E-9FCB-6F12DF209D6E}"/>
+              </a:ext>
+            </a:extLst>
+          </p:cNvPr>
+          <p:cNvSpPr/>
+          <p:nvPr/>
+        </p:nvSpPr>
+        <p:spPr>
+          <a:xfrm>
+            <a:off x="21007435" y="2032719"/>
+            <a:ext cx="202828" cy="202828"/>
+          </a:xfrm>
+          <a:prstGeom prst="sun">
+            <a:avLst/>
+          </a:prstGeom>
+          <a:solidFill>
+            <a:schemeClr val="accent2"/>
+          </a:solidFill>
+        </p:spPr>
+        <p:style>
+          <a:lnRef idx="2">
+            <a:schemeClr val="accent1">
+              <a:shade val="50000"/>
+            </a:schemeClr>
+          </a:lnRef>
+          <a:fillRef idx="1">
+            <a:schemeClr val="accent1"/>
+          </a:fillRef>
+          <a:effectRef idx="0">
+            <a:schemeClr val="accent1"/>
+          </a:effectRef>
+          <a:fontRef idx="minor">
+            <a:schemeClr val="lt1"/>
+          </a:fontRef>
+        </p:style>
+        <p:txBody>
+          <a:bodyPr rtlCol="0" anchor="ctr"/>
+          <a:lstStyle/>
+          <a:p>
+            <a:pPr algn="ctr"/>
+            <a:endParaRPr lang="en-US"/>
+          </a:p>
+        </p:txBody>
+      </p:sp>
+      <p:sp>
+        <p:nvSpPr>
+          <p:cNvPr id="10" name="TextBox 9">
+            <a:extLst>
+              <a:ext uri="{FF2B5EF4-FFF2-40B4-BE49-F238E27FC236}">
+                <a16:creationId xmlns:a16="http://schemas.microsoft.com/office/drawing/2014/main" id="{FC48FAF8-9EFF-5447-B45F-342E51A576D0}"/>
+              </a:ext>
+            </a:extLst>
+          </p:cNvPr>
+          <p:cNvSpPr txBox="1"/>
+          <p:nvPr/>
+        </p:nvSpPr>
+        <p:spPr>
+          <a:xfrm>
+            <a:off x="21416638" y="1730779"/>
+            <a:ext cx="3078479" cy="830997"/>
+          </a:xfrm>
+          <a:prstGeom prst="rect">
+            <a:avLst/>
+          </a:prstGeom>
+          <a:noFill/>
+        </p:spPr>
+        <p:txBody>
+          <a:bodyPr wrap="square" rtlCol="0">
+            <a:spAutoFit/>
+          </a:bodyPr>
+          <a:lstStyle/>
+          <a:p>
+            <a:r>
+              <a:rPr lang="en-US" sz="2400" dirty="0"/>
+              <a:t>Indicates that step has alternate thresholds</a:t>
+            </a:r>
+          </a:p>
+        </p:txBody>
+      </p:sp>
+      <p:sp>
+        <p:nvSpPr>
+          <p:cNvPr id="11" name="Rectangle 10">
+            <a:extLst>
+              <a:ext uri="{FF2B5EF4-FFF2-40B4-BE49-F238E27FC236}">
+                <a16:creationId xmlns:a16="http://schemas.microsoft.com/office/drawing/2014/main" id="{5B1B0A67-B3DD-7F4E-8558-64AC8DB85BFD}"/>
+              </a:ext>
+            </a:extLst>
+          </p:cNvPr>
+          <p:cNvSpPr/>
+          <p:nvPr/>
+        </p:nvSpPr>
+        <p:spPr>
+          <a:xfrm>
+            <a:off x="20885514" y="1575519"/>
+            <a:ext cx="3599671" cy="1103762"/>
+          </a:xfrm>
+          <a:prstGeom prst="rect">
+            <a:avLst/>
+          </a:prstGeom>
+          <a:noFill/>
+          <a:ln>
+            <a:solidFill>
+              <a:schemeClr val="tx1"/>
+            </a:solidFill>
+          </a:ln>
+        </p:spPr>
+        <p:style>
+          <a:lnRef idx="2">
+            <a:schemeClr val="accent1">
+              <a:shade val="50000"/>
+            </a:schemeClr>
+          </a:lnRef>
+          <a:fillRef idx="1">
+            <a:schemeClr val="accent1"/>
+          </a:fillRef>
+          <a:effectRef idx="0">
+            <a:schemeClr val="accent1"/>
+          </a:effectRef>
+          <a:fontRef idx="minor">
+            <a:schemeClr val="lt1"/>
+          </a:fontRef>
+        </p:style>
+        <p:txBody>
+          <a:bodyPr rtlCol="0" anchor="ctr"/>
+          <a:lstStyle/>
+          <a:p>
+            <a:pPr algn="ctr"/>
+            <a:endParaRPr lang="en-US"/>
+          </a:p>
+        </p:txBody>
+      </p:sp>
     </p:spTree>
     <p:extLst>
       <p:ext uri="{BB962C8B-B14F-4D97-AF65-F5344CB8AC3E}">

</xml_diff>